<commit_message>
Tokens poster: results as sentences, morpheme-dotted title, chart without gridlines
Co-Authored-By: Claude Opus 5.5 <noreply@anthropic.com>
Claude-Session: https://claude.ai/code/session_01FqskiptGbZAUC98cS1nW4S
</commit_message>
<xml_diff>
--- a/explorations/tokens-poster/poster-a0.pptx
+++ b/explorations/tokens-poster/poster-a0.pptx
@@ -978,11 +978,11 @@
         <p:spPr>
           <a:xfrm>
             <a:off x="10152309" y="17523744"/>
-            <a:ext cx="19895149" cy="14285580"/>
+            <a:ext cx="19895149" cy="14857080"/>
           </a:xfrm>
           <a:prstGeom prst="roundRect">
             <a:avLst>
-              <a:gd name="adj" fmla="val 2400"/>
+              <a:gd name="adj" fmla="val 2308"/>
             </a:avLst>
           </a:prstGeom>
           <a:solidFill>
@@ -1004,12 +1004,12 @@
         </p:nvSpPr>
         <p:spPr>
           <a:xfrm>
-            <a:off x="10152309" y="32095074"/>
-            <a:ext cx="19895149" cy="9809500"/>
+            <a:off x="10152309" y="32666483"/>
+            <a:ext cx="19895149" cy="9238000"/>
           </a:xfrm>
           <a:prstGeom prst="roundRect">
             <a:avLst>
-              <a:gd name="adj" fmla="val 3496"/>
+              <a:gd name="adj" fmla="val 3712"/>
             </a:avLst>
           </a:prstGeom>
           <a:solidFill>
@@ -1059,7 +1059,211 @@
                 <a:ea typeface="Archivo" pitchFamily="34" charset="-122"/>
                 <a:cs typeface="Archivo" pitchFamily="34" charset="-120"/>
               </a:rPr>
-              <a:t>Tokens of Meaning: Semantically-Informed Morphological Tokenization in Low-Resource Language Modeling</a:t>
+              <a:t>Token</a:t>
+            </a:r>
+            <a:pPr algn="l" indent="0" marL="0">
+              <a:lnSpc>
+                <a:spcPts val="6677"/>
+              </a:lnSpc>
+              <a:buNone/>
+            </a:pPr>
+            <a:r>
+              <a:rPr lang="en-US" sz="6299" b="1" spc="-756" kern="0" dirty="0">
+                <a:solidFill>
+                  <a:srgbClr val="D2601A"/>
+                </a:solidFill>
+                <a:latin typeface="Archivo" pitchFamily="34" charset="0"/>
+                <a:ea typeface="Archivo" pitchFamily="34" charset="-122"/>
+                <a:cs typeface="Archivo" pitchFamily="34" charset="-120"/>
+              </a:rPr>
+              <a:t>·</a:t>
+            </a:r>
+            <a:pPr algn="l" indent="0" marL="0">
+              <a:lnSpc>
+                <a:spcPts val="6677"/>
+              </a:lnSpc>
+              <a:buNone/>
+            </a:pPr>
+            <a:r>
+              <a:rPr lang="en-US" sz="6299" dirty="0">
+                <a:solidFill>
+                  <a:srgbClr val="14161A"/>
+                </a:solidFill>
+                <a:latin typeface="Archivo" pitchFamily="34" charset="0"/>
+                <a:ea typeface="Archivo" pitchFamily="34" charset="-122"/>
+                <a:cs typeface="Archivo" pitchFamily="34" charset="-120"/>
+              </a:rPr>
+              <a:t>s of Mean</a:t>
+            </a:r>
+            <a:pPr algn="l" indent="0" marL="0">
+              <a:lnSpc>
+                <a:spcPts val="6677"/>
+              </a:lnSpc>
+              <a:buNone/>
+            </a:pPr>
+            <a:r>
+              <a:rPr lang="en-US" sz="6299" b="1" spc="-756" kern="0" dirty="0">
+                <a:solidFill>
+                  <a:srgbClr val="D2601A"/>
+                </a:solidFill>
+                <a:latin typeface="Archivo" pitchFamily="34" charset="0"/>
+                <a:ea typeface="Archivo" pitchFamily="34" charset="-122"/>
+                <a:cs typeface="Archivo" pitchFamily="34" charset="-120"/>
+              </a:rPr>
+              <a:t>·</a:t>
+            </a:r>
+            <a:pPr algn="l" indent="0" marL="0">
+              <a:lnSpc>
+                <a:spcPts val="6677"/>
+              </a:lnSpc>
+              <a:buNone/>
+            </a:pPr>
+            <a:r>
+              <a:rPr lang="en-US" sz="6299" dirty="0">
+                <a:solidFill>
+                  <a:srgbClr val="14161A"/>
+                </a:solidFill>
+                <a:latin typeface="Archivo" pitchFamily="34" charset="0"/>
+                <a:ea typeface="Archivo" pitchFamily="34" charset="-122"/>
+                <a:cs typeface="Archivo" pitchFamily="34" charset="-120"/>
+              </a:rPr>
+              <a:t>ing: Semantic</a:t>
+            </a:r>
+            <a:pPr algn="l" indent="0" marL="0">
+              <a:lnSpc>
+                <a:spcPts val="6677"/>
+              </a:lnSpc>
+              <a:buNone/>
+            </a:pPr>
+            <a:r>
+              <a:rPr lang="en-US" sz="6299" b="1" spc="-756" kern="0" dirty="0">
+                <a:solidFill>
+                  <a:srgbClr val="D2601A"/>
+                </a:solidFill>
+                <a:latin typeface="Archivo" pitchFamily="34" charset="0"/>
+                <a:ea typeface="Archivo" pitchFamily="34" charset="-122"/>
+                <a:cs typeface="Archivo" pitchFamily="34" charset="-120"/>
+              </a:rPr>
+              <a:t>·</a:t>
+            </a:r>
+            <a:pPr algn="l" indent="0" marL="0">
+              <a:lnSpc>
+                <a:spcPts val="6677"/>
+              </a:lnSpc>
+              <a:buNone/>
+            </a:pPr>
+            <a:r>
+              <a:rPr lang="en-US" sz="6299" dirty="0">
+                <a:solidFill>
+                  <a:srgbClr val="14161A"/>
+                </a:solidFill>
+                <a:latin typeface="Archivo" pitchFamily="34" charset="0"/>
+                <a:ea typeface="Archivo" pitchFamily="34" charset="-122"/>
+                <a:cs typeface="Archivo" pitchFamily="34" charset="-120"/>
+              </a:rPr>
+              <a:t>ally-Inform</a:t>
+            </a:r>
+            <a:pPr algn="l" indent="0" marL="0">
+              <a:lnSpc>
+                <a:spcPts val="6677"/>
+              </a:lnSpc>
+              <a:buNone/>
+            </a:pPr>
+            <a:r>
+              <a:rPr lang="en-US" sz="6299" b="1" spc="-756" kern="0" dirty="0">
+                <a:solidFill>
+                  <a:srgbClr val="D2601A"/>
+                </a:solidFill>
+                <a:latin typeface="Archivo" pitchFamily="34" charset="0"/>
+                <a:ea typeface="Archivo" pitchFamily="34" charset="-122"/>
+                <a:cs typeface="Archivo" pitchFamily="34" charset="-120"/>
+              </a:rPr>
+              <a:t>·</a:t>
+            </a:r>
+            <a:pPr algn="l" indent="0" marL="0">
+              <a:lnSpc>
+                <a:spcPts val="6677"/>
+              </a:lnSpc>
+              <a:buNone/>
+            </a:pPr>
+            <a:r>
+              <a:rPr lang="en-US" sz="6299" dirty="0">
+                <a:solidFill>
+                  <a:srgbClr val="14161A"/>
+                </a:solidFill>
+                <a:latin typeface="Archivo" pitchFamily="34" charset="0"/>
+                <a:ea typeface="Archivo" pitchFamily="34" charset="-122"/>
+                <a:cs typeface="Archivo" pitchFamily="34" charset="-120"/>
+              </a:rPr>
+              <a:t>ed Morpholog</a:t>
+            </a:r>
+            <a:pPr algn="l" indent="0" marL="0">
+              <a:lnSpc>
+                <a:spcPts val="6677"/>
+              </a:lnSpc>
+              <a:buNone/>
+            </a:pPr>
+            <a:r>
+              <a:rPr lang="en-US" sz="6299" b="1" spc="-756" kern="0" dirty="0">
+                <a:solidFill>
+                  <a:srgbClr val="D2601A"/>
+                </a:solidFill>
+                <a:latin typeface="Archivo" pitchFamily="34" charset="0"/>
+                <a:ea typeface="Archivo" pitchFamily="34" charset="-122"/>
+                <a:cs typeface="Archivo" pitchFamily="34" charset="-120"/>
+              </a:rPr>
+              <a:t>·</a:t>
+            </a:r>
+            <a:pPr algn="l" indent="0" marL="0">
+              <a:lnSpc>
+                <a:spcPts val="6677"/>
+              </a:lnSpc>
+              <a:buNone/>
+            </a:pPr>
+            <a:r>
+              <a:rPr lang="en-US" sz="6299" dirty="0">
+                <a:solidFill>
+                  <a:srgbClr val="14161A"/>
+                </a:solidFill>
+                <a:latin typeface="Archivo" pitchFamily="34" charset="0"/>
+                <a:ea typeface="Archivo" pitchFamily="34" charset="-122"/>
+                <a:cs typeface="Archivo" pitchFamily="34" charset="-120"/>
+              </a:rPr>
+              <a:t>ical Tokenization in Low-Resource Language Model</a:t>
+            </a:r>
+            <a:pPr algn="l" indent="0" marL="0">
+              <a:lnSpc>
+                <a:spcPts val="6677"/>
+              </a:lnSpc>
+              <a:buNone/>
+            </a:pPr>
+            <a:r>
+              <a:rPr lang="en-US" sz="6299" b="1" spc="-756" kern="0" dirty="0">
+                <a:solidFill>
+                  <a:srgbClr val="D2601A"/>
+                </a:solidFill>
+                <a:latin typeface="Archivo" pitchFamily="34" charset="0"/>
+                <a:ea typeface="Archivo" pitchFamily="34" charset="-122"/>
+                <a:cs typeface="Archivo" pitchFamily="34" charset="-120"/>
+              </a:rPr>
+              <a:t>·</a:t>
+            </a:r>
+            <a:pPr algn="l" indent="0" marL="0">
+              <a:lnSpc>
+                <a:spcPts val="6677"/>
+              </a:lnSpc>
+              <a:buNone/>
+            </a:pPr>
+            <a:r>
+              <a:rPr lang="en-US" sz="6299" dirty="0">
+                <a:solidFill>
+                  <a:srgbClr val="14161A"/>
+                </a:solidFill>
+                <a:latin typeface="Archivo" pitchFamily="34" charset="0"/>
+                <a:ea typeface="Archivo" pitchFamily="34" charset="-122"/>
+                <a:cs typeface="Archivo" pitchFamily="34" charset="-120"/>
+              </a:rPr>
+              <a:t>ing</a:t>
             </a:r>
             <a:endParaRPr lang="en-US" sz="6299" dirty="0"/>
           </a:p>
@@ -2642,7 +2846,7 @@
         </p:nvSpPr>
         <p:spPr>
           <a:xfrm>
-            <a:off x="10533248" y="32476013"/>
+            <a:off x="10533248" y="33047422"/>
             <a:ext cx="19285610" cy="629290"/>
           </a:xfrm>
           <a:prstGeom prst="rect">
@@ -2678,14 +2882,14 @@
       </p:sp>
       <p:sp>
         <p:nvSpPr>
-          <p:cNvPr id="44" name="rank-comps"/>
+          <p:cNvPr id="44" name="leaderboard-text"/>
           <p:cNvSpPr txBox="1"/>
           <p:nvPr/>
         </p:nvSpPr>
         <p:spPr>
           <a:xfrm>
-            <a:off x="10533248" y="33523641"/>
-            <a:ext cx="3129260" cy="2128540"/>
+            <a:off x="10533248" y="34095050"/>
+            <a:ext cx="9190452" cy="1338864"/>
           </a:xfrm>
           <a:prstGeom prst="rect">
             <a:avLst/>
@@ -2699,55 +2903,52 @@
           <a:p>
             <a:pPr algn="l" indent="0" marL="0">
               <a:lnSpc>
-                <a:spcPts val="13198"/>
-              </a:lnSpc>
-              <a:buNone/>
-            </a:pPr>
-            <a:r>
-              <a:rPr lang="en-US" sz="13198" b="1" spc="-132" kern="0" dirty="0">
-                <a:solidFill>
-                  <a:srgbClr val="D2601A"/>
-                </a:solidFill>
-                <a:latin typeface="Archivo" pitchFamily="34" charset="0"/>
-                <a:ea typeface="Archivo" pitchFamily="34" charset="-122"/>
-                <a:cs typeface="Archivo" pitchFamily="34" charset="-120"/>
-              </a:rPr>
-              <a:t>2nd</a:t>
-            </a:r>
-            <a:endParaRPr lang="en-US" sz="13198" dirty="0"/>
-          </a:p>
-          <a:p>
-            <a:pPr algn="l" indent="0" marL="0">
-              <a:lnSpc>
-                <a:spcPts val="3562"/>
-              </a:lnSpc>
-              <a:buNone/>
-            </a:pPr>
-            <a:r>
-              <a:rPr lang="en-US" sz="2850" dirty="0">
-                <a:solidFill>
-                  <a:srgbClr val="14161A"/>
-                </a:solidFill>
-                <a:latin typeface="Archivo" pitchFamily="34" charset="0"/>
-                <a:ea typeface="Archivo" pitchFamily="34" charset="-122"/>
-                <a:cs typeface="Archivo" pitchFamily="34" charset="-120"/>
-              </a:rPr>
-              <a:t>on COMPS</a:t>
-            </a:r>
-            <a:endParaRPr lang="en-US" sz="13198" dirty="0"/>
-          </a:p>
-        </p:txBody>
-      </p:sp>
-      <p:sp>
-        <p:nvSpPr>
-          <p:cNvPr id="45" name="rank-ewok"/>
+                <a:spcPts val="3514"/>
+              </a:lnSpc>
+              <a:buNone/>
+            </a:pPr>
+            <a:r>
+              <a:rPr lang="en-US" sz="2475" b="1" dirty="0">
+                <a:solidFill>
+                  <a:srgbClr val="14161A"/>
+                </a:solidFill>
+                <a:latin typeface="Archivo" pitchFamily="34" charset="0"/>
+                <a:ea typeface="Archivo" pitchFamily="34" charset="-122"/>
+                <a:cs typeface="Archivo" pitchFamily="34" charset="-120"/>
+              </a:rPr>
+              <a:t>Leaderboard.</a:t>
+            </a:r>
+            <a:pPr algn="l" indent="0" marL="0">
+              <a:lnSpc>
+                <a:spcPts val="3514"/>
+              </a:lnSpc>
+              <a:buNone/>
+            </a:pPr>
+            <a:r>
+              <a:rPr lang="en-US" sz="2475" dirty="0">
+                <a:solidFill>
+                  <a:srgbClr val="14161A"/>
+                </a:solidFill>
+                <a:latin typeface="Archivo" pitchFamily="34" charset="0"/>
+                <a:ea typeface="Archivo" pitchFamily="34" charset="-122"/>
+                <a:cs typeface="Archivo" pitchFamily="34" charset="-120"/>
+              </a:rPr>
+              <a:t> On the BabyLM 2026 strict-small leaderboard, our submitted model ranks 2nd on COMPS (54.67) and 3rd on EWoK (53.2), with 72.53 on BLiMP.</a:t>
+            </a:r>
+            <a:endParaRPr lang="en-US" sz="2475" dirty="0"/>
+          </a:p>
+        </p:txBody>
+      </p:sp>
+      <p:sp>
+        <p:nvSpPr>
+          <p:cNvPr id="45" name="curation-text"/>
           <p:cNvSpPr txBox="1"/>
           <p:nvPr/>
         </p:nvSpPr>
         <p:spPr>
           <a:xfrm>
-            <a:off x="14081577" y="33523641"/>
-            <a:ext cx="2740457" cy="2128540"/>
+            <a:off x="10533248" y="35814762"/>
+            <a:ext cx="9190452" cy="1338864"/>
           </a:xfrm>
           <a:prstGeom prst="rect">
             <a:avLst/>
@@ -2761,55 +2962,52 @@
           <a:p>
             <a:pPr algn="l" indent="0" marL="0">
               <a:lnSpc>
-                <a:spcPts val="13198"/>
-              </a:lnSpc>
-              <a:buNone/>
-            </a:pPr>
-            <a:r>
-              <a:rPr lang="en-US" sz="13198" b="1" spc="-132" kern="0" dirty="0">
-                <a:solidFill>
-                  <a:srgbClr val="D2601A"/>
-                </a:solidFill>
-                <a:latin typeface="Archivo" pitchFamily="34" charset="0"/>
-                <a:ea typeface="Archivo" pitchFamily="34" charset="-122"/>
-                <a:cs typeface="Archivo" pitchFamily="34" charset="-120"/>
-              </a:rPr>
-              <a:t>3rd</a:t>
-            </a:r>
-            <a:endParaRPr lang="en-US" sz="13198" dirty="0"/>
-          </a:p>
-          <a:p>
-            <a:pPr algn="l" indent="0" marL="0">
-              <a:lnSpc>
-                <a:spcPts val="3562"/>
-              </a:lnSpc>
-              <a:buNone/>
-            </a:pPr>
-            <a:r>
-              <a:rPr lang="en-US" sz="2850" dirty="0">
-                <a:solidFill>
-                  <a:srgbClr val="14161A"/>
-                </a:solidFill>
-                <a:latin typeface="Archivo" pitchFamily="34" charset="0"/>
-                <a:ea typeface="Archivo" pitchFamily="34" charset="-122"/>
-                <a:cs typeface="Archivo" pitchFamily="34" charset="-120"/>
-              </a:rPr>
-              <a:t>on EWoK</a:t>
-            </a:r>
-            <a:endParaRPr lang="en-US" sz="13198" dirty="0"/>
-          </a:p>
-        </p:txBody>
-      </p:sp>
-      <p:sp>
-        <p:nvSpPr>
-          <p:cNvPr id="46" name="leaderboard-note"/>
+                <a:spcPts val="3514"/>
+              </a:lnSpc>
+              <a:buNone/>
+            </a:pPr>
+            <a:r>
+              <a:rPr lang="en-US" sz="2475" b="1" dirty="0">
+                <a:solidFill>
+                  <a:srgbClr val="14161A"/>
+                </a:solidFill>
+                <a:latin typeface="Archivo" pitchFamily="34" charset="0"/>
+                <a:ea typeface="Archivo" pitchFamily="34" charset="-122"/>
+                <a:cs typeface="Archivo" pitchFamily="34" charset="-120"/>
+              </a:rPr>
+              <a:t>Curation is what helps.</a:t>
+            </a:r>
+            <a:pPr algn="l" indent="0" marL="0">
+              <a:lnSpc>
+                <a:spcPts val="3514"/>
+              </a:lnSpc>
+              <a:buNone/>
+            </a:pPr>
+            <a:r>
+              <a:rPr lang="en-US" sz="2475" dirty="0">
+                <a:solidFill>
+                  <a:srgbClr val="14161A"/>
+                </a:solidFill>
+                <a:latin typeface="Archivo" pitchFamily="34" charset="0"/>
+                <a:ea typeface="Archivo" pitchFamily="34" charset="-122"/>
+                <a:cs typeface="Archivo" pitchFamily="34" charset="-120"/>
+              </a:rPr>
+              <a:t> Against an uncurated tokenizer built from the same MorphyNet source, with the same model, data and seed, ours gains +1.4 BLiMP (66.35 vs 64.96).</a:t>
+            </a:r>
+            <a:endParaRPr lang="en-US" sz="2475" dirty="0"/>
+          </a:p>
+        </p:txBody>
+      </p:sp>
+      <p:sp>
+        <p:nvSpPr>
+          <p:cNvPr id="46" name="comps-text"/>
           <p:cNvSpPr txBox="1"/>
           <p:nvPr/>
         </p:nvSpPr>
         <p:spPr>
           <a:xfrm>
-            <a:off x="10533248" y="35842651"/>
-            <a:ext cx="9190452" cy="347015"/>
+            <a:off x="10533248" y="37534566"/>
+            <a:ext cx="9190452" cy="892546"/>
           </a:xfrm>
           <a:prstGeom prst="rect">
             <a:avLst/>
@@ -2823,160 +3021,51 @@
           <a:p>
             <a:pPr algn="l" indent="0" marL="0">
               <a:lnSpc>
-                <a:spcPts val="2733"/>
-              </a:lnSpc>
-              <a:buNone/>
-            </a:pPr>
-            <a:r>
-              <a:rPr lang="en-US" sz="2025" dirty="0">
-                <a:solidFill>
-                  <a:srgbClr val="4A4F57"/>
-                </a:solidFill>
-                <a:latin typeface="Archivo" pitchFamily="34" charset="0"/>
-                <a:ea typeface="Archivo" pitchFamily="34" charset="-122"/>
-                <a:cs typeface="Archivo" pitchFamily="34" charset="-120"/>
-              </a:rPr>
-              <a:t>BabyLM 2026 strict-small leaderboard (BLiMP 72.53).</a:t>
-            </a:r>
-            <a:endParaRPr lang="en-US" sz="2025" dirty="0"/>
-          </a:p>
-        </p:txBody>
-      </p:sp>
-      <p:sp>
-        <p:nvSpPr>
-          <p:cNvPr id="47" name="curation-number"/>
+                <a:spcPts val="3514"/>
+              </a:lnSpc>
+              <a:buNone/>
+            </a:pPr>
+            <a:r>
+              <a:rPr lang="en-US" sz="2475" b="1" dirty="0">
+                <a:solidFill>
+                  <a:srgbClr val="14161A"/>
+                </a:solidFill>
+                <a:latin typeface="Archivo" pitchFamily="34" charset="0"/>
+                <a:ea typeface="Archivo" pitchFamily="34" charset="-122"/>
+                <a:cs typeface="Archivo" pitchFamily="34" charset="-120"/>
+              </a:rPr>
+              <a:t>Concepts.</a:t>
+            </a:r>
+            <a:pPr algn="l" indent="0" marL="0">
+              <a:lnSpc>
+                <a:spcPts val="3514"/>
+              </a:lnSpc>
+              <a:buNone/>
+            </a:pPr>
+            <a:r>
+              <a:rPr lang="en-US" sz="2475" dirty="0">
+                <a:solidFill>
+                  <a:srgbClr val="14161A"/>
+                </a:solidFill>
+                <a:latin typeface="Archivo" pitchFamily="34" charset="0"/>
+                <a:ea typeface="Archivo" pitchFamily="34" charset="-122"/>
+                <a:cs typeface="Archivo" pitchFamily="34" charset="-120"/>
+              </a:rPr>
+              <a:t> On COMPS, the three morphology-based tokenizers take the top three places in that controlled comparison.</a:t>
+            </a:r>
+            <a:endParaRPr lang="en-US" sz="2475" dirty="0"/>
+          </a:p>
+        </p:txBody>
+      </p:sp>
+      <p:sp>
+        <p:nvSpPr>
+          <p:cNvPr id="47" name="chart-title"/>
           <p:cNvSpPr txBox="1"/>
           <p:nvPr/>
         </p:nvSpPr>
         <p:spPr>
           <a:xfrm>
-            <a:off x="10533248" y="36963431"/>
-            <a:ext cx="2953695" cy="1333287"/>
-          </a:xfrm>
-          <a:prstGeom prst="rect">
-            <a:avLst/>
-          </a:prstGeom>
-          <a:noFill/>
-          <a:ln/>
-        </p:spPr>
-        <p:txBody>
-          <a:bodyPr wrap="square" lIns="0" tIns="0" rIns="0" bIns="0" rtlCol="0" anchor="t"/>
-          <a:lstStyle/>
-          <a:p>
-            <a:pPr algn="l" indent="0" marL="0">
-              <a:lnSpc>
-                <a:spcPts val="10499"/>
-              </a:lnSpc>
-              <a:buNone/>
-            </a:pPr>
-            <a:r>
-              <a:rPr lang="en-US" sz="10499" b="1" spc="-105" kern="0" dirty="0">
-                <a:solidFill>
-                  <a:srgbClr val="D2601A"/>
-                </a:solidFill>
-                <a:latin typeface="Archivo" pitchFamily="34" charset="0"/>
-                <a:ea typeface="Archivo" pitchFamily="34" charset="-122"/>
-                <a:cs typeface="Archivo" pitchFamily="34" charset="-120"/>
-              </a:rPr>
-              <a:t>+1.4</a:t>
-            </a:r>
-            <a:endParaRPr lang="en-US" sz="10499" dirty="0"/>
-          </a:p>
-        </p:txBody>
-      </p:sp>
-      <p:sp>
-        <p:nvSpPr>
-          <p:cNvPr id="48" name="curation-text"/>
-          <p:cNvSpPr txBox="1"/>
-          <p:nvPr/>
-        </p:nvSpPr>
-        <p:spPr>
-          <a:xfrm>
-            <a:off x="13639373" y="36951544"/>
-            <a:ext cx="6084326" cy="1357152"/>
-          </a:xfrm>
-          <a:prstGeom prst="rect">
-            <a:avLst/>
-          </a:prstGeom>
-          <a:noFill/>
-          <a:ln/>
-        </p:spPr>
-        <p:txBody>
-          <a:bodyPr wrap="square" lIns="0" tIns="0" rIns="0" bIns="0" rtlCol="0" anchor="t"/>
-          <a:lstStyle/>
-          <a:p>
-            <a:pPr algn="l" indent="0" marL="0">
-              <a:lnSpc>
-                <a:spcPts val="3562"/>
-              </a:lnSpc>
-              <a:buNone/>
-            </a:pPr>
-            <a:r>
-              <a:rPr lang="en-US" sz="2850" dirty="0">
-                <a:solidFill>
-                  <a:srgbClr val="14161A"/>
-                </a:solidFill>
-                <a:latin typeface="Archivo" pitchFamily="34" charset="0"/>
-                <a:ea typeface="Archivo" pitchFamily="34" charset="-122"/>
-                <a:cs typeface="Archivo" pitchFamily="34" charset="-120"/>
-              </a:rPr>
-              <a:t>BLiMP from curation alone: same MorphyNet source, same model, data and seed (66.35 vs 64.96).</a:t>
-            </a:r>
-            <a:endParaRPr lang="en-US" sz="2850" dirty="0"/>
-          </a:p>
-        </p:txBody>
-      </p:sp>
-      <p:sp>
-        <p:nvSpPr>
-          <p:cNvPr id="49" name="comps-note"/>
-          <p:cNvSpPr txBox="1"/>
-          <p:nvPr/>
-        </p:nvSpPr>
-        <p:spPr>
-          <a:xfrm>
-            <a:off x="10533248" y="38632486"/>
-            <a:ext cx="9190452" cy="694030"/>
-          </a:xfrm>
-          <a:prstGeom prst="rect">
-            <a:avLst/>
-          </a:prstGeom>
-          <a:noFill/>
-          <a:ln/>
-        </p:spPr>
-        <p:txBody>
-          <a:bodyPr wrap="square" lIns="0" tIns="0" rIns="0" bIns="0" rtlCol="0" anchor="t"/>
-          <a:lstStyle/>
-          <a:p>
-            <a:pPr algn="l" indent="0" marL="0">
-              <a:lnSpc>
-                <a:spcPts val="2733"/>
-              </a:lnSpc>
-              <a:buNone/>
-            </a:pPr>
-            <a:r>
-              <a:rPr lang="en-US" sz="2025" dirty="0">
-                <a:solidFill>
-                  <a:srgbClr val="4A4F57"/>
-                </a:solidFill>
-                <a:latin typeface="Archivo" pitchFamily="34" charset="0"/>
-                <a:ea typeface="Archivo" pitchFamily="34" charset="-122"/>
-                <a:cs typeface="Archivo" pitchFamily="34" charset="-120"/>
-              </a:rPr>
-              <a:t>On COMPS, the three morphology-based tokenizers take the top three places in the controlled comparison.</a:t>
-            </a:r>
-            <a:endParaRPr lang="en-US" sz="2025" dirty="0"/>
-          </a:p>
-        </p:txBody>
-      </p:sp>
-      <p:sp>
-        <p:nvSpPr>
-          <p:cNvPr id="50" name="chart-title"/>
-          <p:cNvSpPr txBox="1"/>
-          <p:nvPr/>
-        </p:nvSpPr>
-        <p:spPr>
-          <a:xfrm>
-            <a:off x="20437937" y="33523641"/>
+            <a:off x="20437937" y="34095050"/>
             <a:ext cx="9380921" cy="446319"/>
           </a:xfrm>
           <a:prstGeom prst="rect">
@@ -3012,7 +3101,7 @@
       </p:sp>
       <p:pic>
         <p:nvPicPr>
-          <p:cNvPr id="51" name="results-chart" descr="/home/user/claude-sandbox/explorations/tokens-poster/figures/results.png">    </p:cNvPr>
+          <p:cNvPr id="48" name="results-chart" descr="/home/user/claude-sandbox/explorations/tokens-poster/figures/results.png">    </p:cNvPr>
           <p:cNvPicPr>
             <a:picLocks noChangeAspect="1"/>
           </p:cNvPicPr>
@@ -3026,7 +3115,7 @@
         </p:blipFill>
         <p:spPr>
           <a:xfrm>
-            <a:off x="20437937" y="34103188"/>
+            <a:off x="20437937" y="34674597"/>
             <a:ext cx="9228491" cy="5533309"/>
           </a:xfrm>
           <a:prstGeom prst="rect">
@@ -3036,13 +3125,13 @@
       </p:pic>
       <p:sp>
         <p:nvSpPr>
-          <p:cNvPr id="52" name="chart-note"/>
+          <p:cNvPr id="49" name="chart-note"/>
           <p:cNvSpPr txBox="1"/>
           <p:nvPr/>
         </p:nvSpPr>
         <p:spPr>
           <a:xfrm>
-            <a:off x="20437937" y="39769816"/>
+            <a:off x="20437937" y="40341225"/>
             <a:ext cx="9380921" cy="694030"/>
           </a:xfrm>
           <a:prstGeom prst="rect">

</xml_diff>

<commit_message>
Tokens poster: black bullet-operator dots in the title, full Archivo font files for the preview
Co-Authored-By: Claude Opus 5.5 <noreply@anthropic.com>
Claude-Session: https://claude.ai/code/session_01FqskiptGbZAUC98cS1nW4S
</commit_message>
<xml_diff>
--- a/explorations/tokens-poster/poster-a0.pptx
+++ b/explorations/tokens-poster/poster-a0.pptx
@@ -1068,15 +1068,15 @@
               <a:buNone/>
             </a:pPr>
             <a:r>
-              <a:rPr lang="en-US" sz="6299" b="1" spc="-756" kern="0" dirty="0">
-                <a:solidFill>
-                  <a:srgbClr val="D2601A"/>
-                </a:solidFill>
-                <a:latin typeface="Archivo" pitchFamily="34" charset="0"/>
-                <a:ea typeface="Archivo" pitchFamily="34" charset="-122"/>
-                <a:cs typeface="Archivo" pitchFamily="34" charset="-120"/>
-              </a:rPr>
-              <a:t>·</a:t>
+              <a:rPr lang="en-US" sz="7559" b="1" dirty="0">
+                <a:solidFill>
+                  <a:srgbClr val="14161A"/>
+                </a:solidFill>
+                <a:latin typeface="Archivo" pitchFamily="34" charset="0"/>
+                <a:ea typeface="Archivo" pitchFamily="34" charset="-122"/>
+                <a:cs typeface="Archivo" pitchFamily="34" charset="-120"/>
+              </a:rPr>
+              <a:t>∙</a:t>
             </a:r>
             <a:pPr algn="l" indent="0" marL="0">
               <a:lnSpc>
@@ -1102,15 +1102,15 @@
               <a:buNone/>
             </a:pPr>
             <a:r>
-              <a:rPr lang="en-US" sz="6299" b="1" spc="-756" kern="0" dirty="0">
-                <a:solidFill>
-                  <a:srgbClr val="D2601A"/>
-                </a:solidFill>
-                <a:latin typeface="Archivo" pitchFamily="34" charset="0"/>
-                <a:ea typeface="Archivo" pitchFamily="34" charset="-122"/>
-                <a:cs typeface="Archivo" pitchFamily="34" charset="-120"/>
-              </a:rPr>
-              <a:t>·</a:t>
+              <a:rPr lang="en-US" sz="7559" b="1" dirty="0">
+                <a:solidFill>
+                  <a:srgbClr val="14161A"/>
+                </a:solidFill>
+                <a:latin typeface="Archivo" pitchFamily="34" charset="0"/>
+                <a:ea typeface="Archivo" pitchFamily="34" charset="-122"/>
+                <a:cs typeface="Archivo" pitchFamily="34" charset="-120"/>
+              </a:rPr>
+              <a:t>∙</a:t>
             </a:r>
             <a:pPr algn="l" indent="0" marL="0">
               <a:lnSpc>
@@ -1136,15 +1136,15 @@
               <a:buNone/>
             </a:pPr>
             <a:r>
-              <a:rPr lang="en-US" sz="6299" b="1" spc="-756" kern="0" dirty="0">
-                <a:solidFill>
-                  <a:srgbClr val="D2601A"/>
-                </a:solidFill>
-                <a:latin typeface="Archivo" pitchFamily="34" charset="0"/>
-                <a:ea typeface="Archivo" pitchFamily="34" charset="-122"/>
-                <a:cs typeface="Archivo" pitchFamily="34" charset="-120"/>
-              </a:rPr>
-              <a:t>·</a:t>
+              <a:rPr lang="en-US" sz="7559" b="1" dirty="0">
+                <a:solidFill>
+                  <a:srgbClr val="14161A"/>
+                </a:solidFill>
+                <a:latin typeface="Archivo" pitchFamily="34" charset="0"/>
+                <a:ea typeface="Archivo" pitchFamily="34" charset="-122"/>
+                <a:cs typeface="Archivo" pitchFamily="34" charset="-120"/>
+              </a:rPr>
+              <a:t>∙</a:t>
             </a:r>
             <a:pPr algn="l" indent="0" marL="0">
               <a:lnSpc>
@@ -1170,15 +1170,15 @@
               <a:buNone/>
             </a:pPr>
             <a:r>
-              <a:rPr lang="en-US" sz="6299" b="1" spc="-756" kern="0" dirty="0">
-                <a:solidFill>
-                  <a:srgbClr val="D2601A"/>
-                </a:solidFill>
-                <a:latin typeface="Archivo" pitchFamily="34" charset="0"/>
-                <a:ea typeface="Archivo" pitchFamily="34" charset="-122"/>
-                <a:cs typeface="Archivo" pitchFamily="34" charset="-120"/>
-              </a:rPr>
-              <a:t>·</a:t>
+              <a:rPr lang="en-US" sz="7559" b="1" dirty="0">
+                <a:solidFill>
+                  <a:srgbClr val="14161A"/>
+                </a:solidFill>
+                <a:latin typeface="Archivo" pitchFamily="34" charset="0"/>
+                <a:ea typeface="Archivo" pitchFamily="34" charset="-122"/>
+                <a:cs typeface="Archivo" pitchFamily="34" charset="-120"/>
+              </a:rPr>
+              <a:t>∙</a:t>
             </a:r>
             <a:pPr algn="l" indent="0" marL="0">
               <a:lnSpc>
@@ -1204,15 +1204,15 @@
               <a:buNone/>
             </a:pPr>
             <a:r>
-              <a:rPr lang="en-US" sz="6299" b="1" spc="-756" kern="0" dirty="0">
-                <a:solidFill>
-                  <a:srgbClr val="D2601A"/>
-                </a:solidFill>
-                <a:latin typeface="Archivo" pitchFamily="34" charset="0"/>
-                <a:ea typeface="Archivo" pitchFamily="34" charset="-122"/>
-                <a:cs typeface="Archivo" pitchFamily="34" charset="-120"/>
-              </a:rPr>
-              <a:t>·</a:t>
+              <a:rPr lang="en-US" sz="7559" b="1" dirty="0">
+                <a:solidFill>
+                  <a:srgbClr val="14161A"/>
+                </a:solidFill>
+                <a:latin typeface="Archivo" pitchFamily="34" charset="0"/>
+                <a:ea typeface="Archivo" pitchFamily="34" charset="-122"/>
+                <a:cs typeface="Archivo" pitchFamily="34" charset="-120"/>
+              </a:rPr>
+              <a:t>∙</a:t>
             </a:r>
             <a:pPr algn="l" indent="0" marL="0">
               <a:lnSpc>
@@ -1238,15 +1238,15 @@
               <a:buNone/>
             </a:pPr>
             <a:r>
-              <a:rPr lang="en-US" sz="6299" b="1" spc="-756" kern="0" dirty="0">
-                <a:solidFill>
-                  <a:srgbClr val="D2601A"/>
-                </a:solidFill>
-                <a:latin typeface="Archivo" pitchFamily="34" charset="0"/>
-                <a:ea typeface="Archivo" pitchFamily="34" charset="-122"/>
-                <a:cs typeface="Archivo" pitchFamily="34" charset="-120"/>
-              </a:rPr>
-              <a:t>·</a:t>
+              <a:rPr lang="en-US" sz="7559" b="1" dirty="0">
+                <a:solidFill>
+                  <a:srgbClr val="14161A"/>
+                </a:solidFill>
+                <a:latin typeface="Archivo" pitchFamily="34" charset="0"/>
+                <a:ea typeface="Archivo" pitchFamily="34" charset="-122"/>
+                <a:cs typeface="Archivo" pitchFamily="34" charset="-120"/>
+              </a:rPr>
+              <a:t>∙</a:t>
             </a:r>
             <a:pPr algn="l" indent="0" marL="0">
               <a:lnSpc>

</xml_diff>

<commit_message>
Tokens poster: plain title again, morpheme dots in the banner instead
Co-Authored-By: Claude Opus 5.5 <noreply@anthropic.com>
Claude-Session: https://claude.ai/code/session_01FqskiptGbZAUC98cS1nW4S
</commit_message>
<xml_diff>
--- a/explorations/tokens-poster/poster-a0.pptx
+++ b/explorations/tokens-poster/poster-a0.pptx
@@ -1059,211 +1059,7 @@
                 <a:ea typeface="Archivo" pitchFamily="34" charset="-122"/>
                 <a:cs typeface="Archivo" pitchFamily="34" charset="-120"/>
               </a:rPr>
-              <a:t>Token</a:t>
-            </a:r>
-            <a:pPr algn="l" indent="0" marL="0">
-              <a:lnSpc>
-                <a:spcPts val="6677"/>
-              </a:lnSpc>
-              <a:buNone/>
-            </a:pPr>
-            <a:r>
-              <a:rPr lang="en-US" sz="7559" b="1" dirty="0">
-                <a:solidFill>
-                  <a:srgbClr val="14161A"/>
-                </a:solidFill>
-                <a:latin typeface="Archivo" pitchFamily="34" charset="0"/>
-                <a:ea typeface="Archivo" pitchFamily="34" charset="-122"/>
-                <a:cs typeface="Archivo" pitchFamily="34" charset="-120"/>
-              </a:rPr>
-              <a:t>∙</a:t>
-            </a:r>
-            <a:pPr algn="l" indent="0" marL="0">
-              <a:lnSpc>
-                <a:spcPts val="6677"/>
-              </a:lnSpc>
-              <a:buNone/>
-            </a:pPr>
-            <a:r>
-              <a:rPr lang="en-US" sz="6299" dirty="0">
-                <a:solidFill>
-                  <a:srgbClr val="14161A"/>
-                </a:solidFill>
-                <a:latin typeface="Archivo" pitchFamily="34" charset="0"/>
-                <a:ea typeface="Archivo" pitchFamily="34" charset="-122"/>
-                <a:cs typeface="Archivo" pitchFamily="34" charset="-120"/>
-              </a:rPr>
-              <a:t>s of Mean</a:t>
-            </a:r>
-            <a:pPr algn="l" indent="0" marL="0">
-              <a:lnSpc>
-                <a:spcPts val="6677"/>
-              </a:lnSpc>
-              <a:buNone/>
-            </a:pPr>
-            <a:r>
-              <a:rPr lang="en-US" sz="7559" b="1" dirty="0">
-                <a:solidFill>
-                  <a:srgbClr val="14161A"/>
-                </a:solidFill>
-                <a:latin typeface="Archivo" pitchFamily="34" charset="0"/>
-                <a:ea typeface="Archivo" pitchFamily="34" charset="-122"/>
-                <a:cs typeface="Archivo" pitchFamily="34" charset="-120"/>
-              </a:rPr>
-              <a:t>∙</a:t>
-            </a:r>
-            <a:pPr algn="l" indent="0" marL="0">
-              <a:lnSpc>
-                <a:spcPts val="6677"/>
-              </a:lnSpc>
-              <a:buNone/>
-            </a:pPr>
-            <a:r>
-              <a:rPr lang="en-US" sz="6299" dirty="0">
-                <a:solidFill>
-                  <a:srgbClr val="14161A"/>
-                </a:solidFill>
-                <a:latin typeface="Archivo" pitchFamily="34" charset="0"/>
-                <a:ea typeface="Archivo" pitchFamily="34" charset="-122"/>
-                <a:cs typeface="Archivo" pitchFamily="34" charset="-120"/>
-              </a:rPr>
-              <a:t>ing: Semantic</a:t>
-            </a:r>
-            <a:pPr algn="l" indent="0" marL="0">
-              <a:lnSpc>
-                <a:spcPts val="6677"/>
-              </a:lnSpc>
-              <a:buNone/>
-            </a:pPr>
-            <a:r>
-              <a:rPr lang="en-US" sz="7559" b="1" dirty="0">
-                <a:solidFill>
-                  <a:srgbClr val="14161A"/>
-                </a:solidFill>
-                <a:latin typeface="Archivo" pitchFamily="34" charset="0"/>
-                <a:ea typeface="Archivo" pitchFamily="34" charset="-122"/>
-                <a:cs typeface="Archivo" pitchFamily="34" charset="-120"/>
-              </a:rPr>
-              <a:t>∙</a:t>
-            </a:r>
-            <a:pPr algn="l" indent="0" marL="0">
-              <a:lnSpc>
-                <a:spcPts val="6677"/>
-              </a:lnSpc>
-              <a:buNone/>
-            </a:pPr>
-            <a:r>
-              <a:rPr lang="en-US" sz="6299" dirty="0">
-                <a:solidFill>
-                  <a:srgbClr val="14161A"/>
-                </a:solidFill>
-                <a:latin typeface="Archivo" pitchFamily="34" charset="0"/>
-                <a:ea typeface="Archivo" pitchFamily="34" charset="-122"/>
-                <a:cs typeface="Archivo" pitchFamily="34" charset="-120"/>
-              </a:rPr>
-              <a:t>ally-Inform</a:t>
-            </a:r>
-            <a:pPr algn="l" indent="0" marL="0">
-              <a:lnSpc>
-                <a:spcPts val="6677"/>
-              </a:lnSpc>
-              <a:buNone/>
-            </a:pPr>
-            <a:r>
-              <a:rPr lang="en-US" sz="7559" b="1" dirty="0">
-                <a:solidFill>
-                  <a:srgbClr val="14161A"/>
-                </a:solidFill>
-                <a:latin typeface="Archivo" pitchFamily="34" charset="0"/>
-                <a:ea typeface="Archivo" pitchFamily="34" charset="-122"/>
-                <a:cs typeface="Archivo" pitchFamily="34" charset="-120"/>
-              </a:rPr>
-              <a:t>∙</a:t>
-            </a:r>
-            <a:pPr algn="l" indent="0" marL="0">
-              <a:lnSpc>
-                <a:spcPts val="6677"/>
-              </a:lnSpc>
-              <a:buNone/>
-            </a:pPr>
-            <a:r>
-              <a:rPr lang="en-US" sz="6299" dirty="0">
-                <a:solidFill>
-                  <a:srgbClr val="14161A"/>
-                </a:solidFill>
-                <a:latin typeface="Archivo" pitchFamily="34" charset="0"/>
-                <a:ea typeface="Archivo" pitchFamily="34" charset="-122"/>
-                <a:cs typeface="Archivo" pitchFamily="34" charset="-120"/>
-              </a:rPr>
-              <a:t>ed Morpholog</a:t>
-            </a:r>
-            <a:pPr algn="l" indent="0" marL="0">
-              <a:lnSpc>
-                <a:spcPts val="6677"/>
-              </a:lnSpc>
-              <a:buNone/>
-            </a:pPr>
-            <a:r>
-              <a:rPr lang="en-US" sz="7559" b="1" dirty="0">
-                <a:solidFill>
-                  <a:srgbClr val="14161A"/>
-                </a:solidFill>
-                <a:latin typeface="Archivo" pitchFamily="34" charset="0"/>
-                <a:ea typeface="Archivo" pitchFamily="34" charset="-122"/>
-                <a:cs typeface="Archivo" pitchFamily="34" charset="-120"/>
-              </a:rPr>
-              <a:t>∙</a:t>
-            </a:r>
-            <a:pPr algn="l" indent="0" marL="0">
-              <a:lnSpc>
-                <a:spcPts val="6677"/>
-              </a:lnSpc>
-              <a:buNone/>
-            </a:pPr>
-            <a:r>
-              <a:rPr lang="en-US" sz="6299" dirty="0">
-                <a:solidFill>
-                  <a:srgbClr val="14161A"/>
-                </a:solidFill>
-                <a:latin typeface="Archivo" pitchFamily="34" charset="0"/>
-                <a:ea typeface="Archivo" pitchFamily="34" charset="-122"/>
-                <a:cs typeface="Archivo" pitchFamily="34" charset="-120"/>
-              </a:rPr>
-              <a:t>ical Tokenization in Low-Resource Language Model</a:t>
-            </a:r>
-            <a:pPr algn="l" indent="0" marL="0">
-              <a:lnSpc>
-                <a:spcPts val="6677"/>
-              </a:lnSpc>
-              <a:buNone/>
-            </a:pPr>
-            <a:r>
-              <a:rPr lang="en-US" sz="7559" b="1" dirty="0">
-                <a:solidFill>
-                  <a:srgbClr val="14161A"/>
-                </a:solidFill>
-                <a:latin typeface="Archivo" pitchFamily="34" charset="0"/>
-                <a:ea typeface="Archivo" pitchFamily="34" charset="-122"/>
-                <a:cs typeface="Archivo" pitchFamily="34" charset="-120"/>
-              </a:rPr>
-              <a:t>∙</a:t>
-            </a:r>
-            <a:pPr algn="l" indent="0" marL="0">
-              <a:lnSpc>
-                <a:spcPts val="6677"/>
-              </a:lnSpc>
-              <a:buNone/>
-            </a:pPr>
-            <a:r>
-              <a:rPr lang="en-US" sz="6299" dirty="0">
-                <a:solidFill>
-                  <a:srgbClr val="14161A"/>
-                </a:solidFill>
-                <a:latin typeface="Archivo" pitchFamily="34" charset="0"/>
-                <a:ea typeface="Archivo" pitchFamily="34" charset="-122"/>
-                <a:cs typeface="Archivo" pitchFamily="34" charset="-120"/>
-              </a:rPr>
-              <a:t>ing</a:t>
+              <a:t>Tokens of Meaning: Semantically-Informed Morphological Tokenization in Low-Resource Language Modeling</a:t>
             </a:r>
             <a:endParaRPr lang="en-US" sz="6299" dirty="0"/>
           </a:p>
@@ -1414,7 +1210,7 @@
                 <a:ea typeface="Archivo" pitchFamily="34" charset="-122"/>
                 <a:cs typeface="Archivo" pitchFamily="34" charset="-120"/>
               </a:rPr>
-              <a:t>Split words into </a:t>
+              <a:t>Split word</a:t>
             </a:r>
             <a:pPr algn="l" indent="0" marL="0">
               <a:lnSpc>
@@ -1423,15 +1219,83 @@
               <a:buNone/>
             </a:pPr>
             <a:r>
+              <a:rPr lang="en-US" sz="18538" b="1" spc="-154" kern="0" dirty="0">
+                <a:solidFill>
+                  <a:srgbClr val="14161A"/>
+                </a:solidFill>
+                <a:latin typeface="Archivo" pitchFamily="34" charset="0"/>
+                <a:ea typeface="Archivo" pitchFamily="34" charset="-122"/>
+                <a:cs typeface="Archivo" pitchFamily="34" charset="-120"/>
+              </a:rPr>
+              <a:t>∙</a:t>
+            </a:r>
+            <a:pPr algn="l" indent="0" marL="0">
+              <a:lnSpc>
+                <a:spcPts val="16220"/>
+              </a:lnSpc>
+              <a:buNone/>
+            </a:pPr>
+            <a:r>
               <a:rPr lang="en-US" sz="15448" spc="-154" kern="0" dirty="0">
                 <a:solidFill>
+                  <a:srgbClr val="14161A"/>
+                </a:solidFill>
+                <a:latin typeface="Archivo" pitchFamily="34" charset="0"/>
+                <a:ea typeface="Archivo" pitchFamily="34" charset="-122"/>
+                <a:cs typeface="Archivo" pitchFamily="34" charset="-120"/>
+              </a:rPr>
+              <a:t>s into </a:t>
+            </a:r>
+            <a:pPr algn="l" indent="0" marL="0">
+              <a:lnSpc>
+                <a:spcPts val="16220"/>
+              </a:lnSpc>
+              <a:buNone/>
+            </a:pPr>
+            <a:r>
+              <a:rPr lang="en-US" sz="15448" spc="-154" kern="0" dirty="0">
+                <a:solidFill>
                   <a:srgbClr val="BD0700"/>
                 </a:solidFill>
                 <a:latin typeface="Archivo" pitchFamily="34" charset="0"/>
                 <a:ea typeface="Archivo" pitchFamily="34" charset="-122"/>
                 <a:cs typeface="Archivo" pitchFamily="34" charset="-120"/>
               </a:rPr>
-              <a:t>morphemes</a:t>
+              <a:t>morpheme</a:t>
+            </a:r>
+            <a:pPr algn="l" indent="0" marL="0">
+              <a:lnSpc>
+                <a:spcPts val="16220"/>
+              </a:lnSpc>
+              <a:buNone/>
+            </a:pPr>
+            <a:r>
+              <a:rPr lang="en-US" sz="18538" b="1" spc="-154" kern="0" dirty="0">
+                <a:solidFill>
+                  <a:srgbClr val="BD0700"/>
+                </a:solidFill>
+                <a:latin typeface="Archivo" pitchFamily="34" charset="0"/>
+                <a:ea typeface="Archivo" pitchFamily="34" charset="-122"/>
+                <a:cs typeface="Archivo" pitchFamily="34" charset="-120"/>
+              </a:rPr>
+              <a:t>∙</a:t>
+            </a:r>
+            <a:pPr algn="l" indent="0" marL="0">
+              <a:lnSpc>
+                <a:spcPts val="16220"/>
+              </a:lnSpc>
+              <a:buNone/>
+            </a:pPr>
+            <a:r>
+              <a:rPr lang="en-US" sz="15448" spc="-154" kern="0" dirty="0">
+                <a:solidFill>
+                  <a:srgbClr val="BD0700"/>
+                </a:solidFill>
+                <a:latin typeface="Archivo" pitchFamily="34" charset="0"/>
+                <a:ea typeface="Archivo" pitchFamily="34" charset="-122"/>
+                <a:cs typeface="Archivo" pitchFamily="34" charset="-120"/>
+              </a:rPr>
+              <a:t>s</a:t>
             </a:r>
             <a:endParaRPr lang="en-US" sz="15448" dirty="0"/>
           </a:p>
@@ -1451,7 +1315,7 @@
                 <a:ea typeface="Archivo" pitchFamily="34" charset="-122"/>
                 <a:cs typeface="Archivo" pitchFamily="34" charset="-120"/>
               </a:rPr>
-              <a:t>only when the pieces keep the </a:t>
+              <a:t>only when the piece</a:t>
             </a:r>
             <a:pPr algn="l" indent="0" marL="0">
               <a:lnSpc>
@@ -1460,15 +1324,83 @@
               <a:buNone/>
             </a:pPr>
             <a:r>
+              <a:rPr lang="en-US" sz="13498" b="1" i="1" dirty="0">
+                <a:solidFill>
+                  <a:srgbClr val="14161A"/>
+                </a:solidFill>
+                <a:latin typeface="Archivo" pitchFamily="34" charset="0"/>
+                <a:ea typeface="Archivo" pitchFamily="34" charset="-122"/>
+                <a:cs typeface="Archivo" pitchFamily="34" charset="-120"/>
+              </a:rPr>
+              <a:t>∙</a:t>
+            </a:r>
+            <a:pPr algn="l" indent="0" marL="0">
+              <a:lnSpc>
+                <a:spcPts val="12598"/>
+              </a:lnSpc>
+              <a:buNone/>
+            </a:pPr>
+            <a:r>
               <a:rPr lang="en-US" sz="11249" i="1" dirty="0">
                 <a:solidFill>
+                  <a:srgbClr val="14161A"/>
+                </a:solidFill>
+                <a:latin typeface="Archivo" pitchFamily="34" charset="0"/>
+                <a:ea typeface="Archivo" pitchFamily="34" charset="-122"/>
+                <a:cs typeface="Archivo" pitchFamily="34" charset="-120"/>
+              </a:rPr>
+              <a:t>s keep the </a:t>
+            </a:r>
+            <a:pPr algn="l" indent="0" marL="0">
+              <a:lnSpc>
+                <a:spcPts val="12598"/>
+              </a:lnSpc>
+              <a:buNone/>
+            </a:pPr>
+            <a:r>
+              <a:rPr lang="en-US" sz="11249" i="1" dirty="0">
+                <a:solidFill>
                   <a:srgbClr val="BD0700"/>
                 </a:solidFill>
                 <a:latin typeface="Archivo" pitchFamily="34" charset="0"/>
                 <a:ea typeface="Archivo" pitchFamily="34" charset="-122"/>
                 <a:cs typeface="Archivo" pitchFamily="34" charset="-120"/>
               </a:rPr>
-              <a:t>meaning</a:t>
+              <a:t>mean</a:t>
+            </a:r>
+            <a:pPr algn="l" indent="0" marL="0">
+              <a:lnSpc>
+                <a:spcPts val="12598"/>
+              </a:lnSpc>
+              <a:buNone/>
+            </a:pPr>
+            <a:r>
+              <a:rPr lang="en-US" sz="13498" b="1" i="1" dirty="0">
+                <a:solidFill>
+                  <a:srgbClr val="BD0700"/>
+                </a:solidFill>
+                <a:latin typeface="Archivo" pitchFamily="34" charset="0"/>
+                <a:ea typeface="Archivo" pitchFamily="34" charset="-122"/>
+                <a:cs typeface="Archivo" pitchFamily="34" charset="-120"/>
+              </a:rPr>
+              <a:t>∙</a:t>
+            </a:r>
+            <a:pPr algn="l" indent="0" marL="0">
+              <a:lnSpc>
+                <a:spcPts val="12598"/>
+              </a:lnSpc>
+              <a:buNone/>
+            </a:pPr>
+            <a:r>
+              <a:rPr lang="en-US" sz="11249" i="1" dirty="0">
+                <a:solidFill>
+                  <a:srgbClr val="BD0700"/>
+                </a:solidFill>
+                <a:latin typeface="Archivo" pitchFamily="34" charset="0"/>
+                <a:ea typeface="Archivo" pitchFamily="34" charset="-122"/>
+                <a:cs typeface="Archivo" pitchFamily="34" charset="-120"/>
+              </a:rPr>
+              <a:t>ing</a:t>
             </a:r>
             <a:endParaRPr lang="en-US" sz="15448" dirty="0"/>
           </a:p>

</xml_diff>